<commit_message>
chore: regenerate example PDFs and decks on CI with the Inter font
Co-authored-by: Cursor <cursoragent@cursor.com>
</commit_message>
<xml_diff>
--- a/plugins/gradient-cio/assets/examples/gradient-decision-ic-memo.pptx
+++ b/plugins/gradient-cio/assets/examples/gradient-decision-ic-memo.pptx
@@ -8147,7 +8147,7 @@
               <a:rPr>
                 <a:latin typeface="Inter"/>
               </a:rPr>
-              <a:t>•  Summary:** 6 Compliant, 1 Watch, 2 Breach, 3 Not assessed.</a:t>
+              <a:t>•  Summary:** 6 Compliant, 1 Near limit, 2 Breach, 3 Not assessed.</a:t>
             </a:r>
           </a:p>
           <a:p>
@@ -13574,7 +13574,7 @@
               <a:rPr>
                 <a:latin typeface="Inter"/>
               </a:rPr>
-              <a:t>1 additional Watch [S1]</a:t>
+              <a:t>1 more near its limit [S1]</a:t>
             </a:r>
           </a:p>
         </p:txBody>
@@ -28728,7 +28728,7 @@
               <a:rPr>
                 <a:latin typeface="Inter"/>
               </a:rPr>
-              <a:t>•  IPS:** 6 constraints Compliant, 1 Watch, 2 Breach, 3 Not assessed. Breaches: fixed income band and cash band.</a:t>
+              <a:t>•  IPS:** 6 constraints Compliant, 1 Near limit, 2 Breach, 3 Not assessed. Breaches: fixed income band and cash band.</a:t>
             </a:r>
           </a:p>
           <a:p>

</xml_diff>

<commit_message>
fix: unblock triage and portfolio review examples and refresh references
The roster triage layout budget listed single-manager ODD sections, so every triage report failed pre-render QA. The comprehensive portfolio review example declared a forced break outside its budget and never rendered. Example generation now fails when an example is rejected before rendering, and the reference examples are regenerated for the 6.1.x renderer changes and consolidated mode names.

Co-authored-by: Cursor <cursoragent@cursor.com>
</commit_message>
<xml_diff>
--- a/plugins/gradient-cio/assets/examples/gradient-decision-ic-memo.pptx
+++ b/plugins/gradient-cio/assets/examples/gradient-decision-ic-memo.pptx
@@ -35824,7 +35824,7 @@
               <a:rPr>
                 <a:latin typeface="Inter"/>
               </a:rPr>
-              <a:t> ·  S6  ·  get_chart_data  ·  gradient_tool  ·  get_chart_data  ·  portfolio_id=example; analysis_type=allocations  ·  2026-09-30  ·  Illustrative, Gradient Maintained — demo data, not the client's holdings or managers  ·  passed  ·  sha256:test-s6  · </a:t>
+              <a:t> ·  S6  ·  get_portfolio_exposure  ·  gradient_tool  ·  get_portfolio_exposure  ·  portfolio_id=example; include=factor_currency_exposure,risk_contribution  ·  2026-09-30  ·  Illustrative, Gradient Maintained — demo data, not the client's holdings or managers  ·  passed  ·  sha256:test-s6  · </a:t>
             </a:r>
             <a:br/>
             <a:br/>
@@ -35848,7 +35848,7 @@
               <a:rPr>
                 <a:latin typeface="Inter"/>
               </a:rPr>
-              <a:t> ·  S9  ·  get_chart_data  ·  gradient_tool  ·  get_chart_data  ·  portfolio_id=example; analysis_type=commitments  ·  2026-06-30  ·  Illustrative, Gradient Maintained — demo data, not the client's holdings or managers  ·  passed  ·  sha256:test-s9  · </a:t>
+              <a:t> ·  S9  ·  get_portfolio_exposure  ·  gradient_tool  ·  get_portfolio_exposure  ·  portfolio_id=example; include=commitment_pacing,liquidity_scorecard  ·  2026-06-30  ·  Illustrative, Gradient Maintained — demo data, not the client's holdings or managers  ·  passed  ·  sha256:test-s9  · </a:t>
             </a:r>
             <a:br/>
             <a:br/>

</xml_diff>